<commit_message>
fix(test): correct char positions for revenue/link in text_v3 fixture
Spec review caught off-by-one: "revenue" starts at char 19 (not 20),
"link" starts at char 21 (not 22). 1-indexed PowerPoint Characters
counting confirmed by manual verification.

Plan code blocks updated alongside source so subsequent tasks reference
correct positions.

Co-Authored-By: Claude Opus 4.7 (1M context) <noreply@anthropic.com>
</commit_message>
<xml_diff>
--- a/test_decks/text_v3.pptx
+++ b/test_decks/text_v3.pptx
@@ -132,7 +132,7 @@
           <p:cNvPr id="2" name="Title 1">
             <a:extLst>
               <a:ext uri="{FF2B5EF4-FFF2-40B4-BE49-F238E27FC236}">
-                <a16:creationId xmlns:a16="http://schemas.microsoft.com/office/drawing/2014/main" id="{A7C12B69-5EB3-2800-B604-B787D48551EE}"/>
+                <a16:creationId xmlns:a16="http://schemas.microsoft.com/office/drawing/2014/main" id="{F0AB24E9-17C2-0D68-600C-ED316268943D}"/>
               </a:ext>
             </a:extLst>
           </p:cNvPr>
@@ -170,7 +170,7 @@
           <p:cNvPr id="3" name="Subtitle 2">
             <a:extLst>
               <a:ext uri="{FF2B5EF4-FFF2-40B4-BE49-F238E27FC236}">
-                <a16:creationId xmlns:a16="http://schemas.microsoft.com/office/drawing/2014/main" id="{3DE5A511-5746-5C31-49B0-D86A3A6E7943}"/>
+                <a16:creationId xmlns:a16="http://schemas.microsoft.com/office/drawing/2014/main" id="{9877692E-7A21-8038-FDB6-EB18CC48BF9C}"/>
               </a:ext>
             </a:extLst>
           </p:cNvPr>
@@ -241,7 +241,7 @@
           <p:cNvPr id="4" name="Date Placeholder 3">
             <a:extLst>
               <a:ext uri="{FF2B5EF4-FFF2-40B4-BE49-F238E27FC236}">
-                <a16:creationId xmlns:a16="http://schemas.microsoft.com/office/drawing/2014/main" id="{FF66B6CA-8A43-BBB3-6332-105D771818AF}"/>
+                <a16:creationId xmlns:a16="http://schemas.microsoft.com/office/drawing/2014/main" id="{FA67A279-EEDD-6583-9799-962F461AD73A}"/>
               </a:ext>
             </a:extLst>
           </p:cNvPr>
@@ -257,7 +257,7 @@
           <a:bodyPr/>
           <a:lstStyle/>
           <a:p>
-            <a:fld id="{7CBE9ABB-B08B-4478-9A87-2E9A09899291}" type="datetimeFigureOut">
+            <a:fld id="{E9FEBD7B-8EB1-423A-95BC-1767948C3A44}" type="datetimeFigureOut">
               <a:rPr lang="en-IN" smtClean="0"/>
               <a:t>09-05-2026</a:t>
             </a:fld>
@@ -270,7 +270,7 @@
           <p:cNvPr id="5" name="Footer Placeholder 4">
             <a:extLst>
               <a:ext uri="{FF2B5EF4-FFF2-40B4-BE49-F238E27FC236}">
-                <a16:creationId xmlns:a16="http://schemas.microsoft.com/office/drawing/2014/main" id="{12FF4230-9F03-3174-EE7D-384350C8A163}"/>
+                <a16:creationId xmlns:a16="http://schemas.microsoft.com/office/drawing/2014/main" id="{2D2B9CDC-5481-32F2-9FCB-0FF2BB5895D0}"/>
               </a:ext>
             </a:extLst>
           </p:cNvPr>
@@ -295,7 +295,7 @@
           <p:cNvPr id="6" name="Slide Number Placeholder 5">
             <a:extLst>
               <a:ext uri="{FF2B5EF4-FFF2-40B4-BE49-F238E27FC236}">
-                <a16:creationId xmlns:a16="http://schemas.microsoft.com/office/drawing/2014/main" id="{EFE44262-9B53-9201-A6BA-8A450FC4C8CF}"/>
+                <a16:creationId xmlns:a16="http://schemas.microsoft.com/office/drawing/2014/main" id="{FFC15518-A9B7-114D-5CC9-1F6F1FF376A9}"/>
               </a:ext>
             </a:extLst>
           </p:cNvPr>
@@ -311,7 +311,7 @@
           <a:bodyPr/>
           <a:lstStyle/>
           <a:p>
-            <a:fld id="{29FAEB51-C480-4927-8D63-D7E8CA2D0755}" type="slidenum">
+            <a:fld id="{7D3154C7-F847-4D8D-B672-35AC6CDDB69A}" type="slidenum">
               <a:rPr lang="en-IN" smtClean="0"/>
               <a:t>‹#›</a:t>
             </a:fld>
@@ -322,7 +322,7 @@
     </p:spTree>
     <p:extLst>
       <p:ext uri="{BB962C8B-B14F-4D97-AF65-F5344CB8AC3E}">
-        <p14:creationId xmlns:p14="http://schemas.microsoft.com/office/powerpoint/2010/main" val="925910357"/>
+        <p14:creationId xmlns:p14="http://schemas.microsoft.com/office/powerpoint/2010/main" val="2856597717"/>
       </p:ext>
     </p:extLst>
   </p:cSld>
@@ -354,7 +354,7 @@
           <p:cNvPr id="2" name="Title 1">
             <a:extLst>
               <a:ext uri="{FF2B5EF4-FFF2-40B4-BE49-F238E27FC236}">
-                <a16:creationId xmlns:a16="http://schemas.microsoft.com/office/drawing/2014/main" id="{AE5C981B-8911-EF09-B632-D03A311A22DE}"/>
+                <a16:creationId xmlns:a16="http://schemas.microsoft.com/office/drawing/2014/main" id="{483B2857-3BBD-7240-F9F1-9F9D5C2E1406}"/>
               </a:ext>
             </a:extLst>
           </p:cNvPr>
@@ -383,7 +383,7 @@
           <p:cNvPr id="3" name="Vertical Text Placeholder 2">
             <a:extLst>
               <a:ext uri="{FF2B5EF4-FFF2-40B4-BE49-F238E27FC236}">
-                <a16:creationId xmlns:a16="http://schemas.microsoft.com/office/drawing/2014/main" id="{E0219493-CB4A-B938-57F0-2BD8EDA92254}"/>
+                <a16:creationId xmlns:a16="http://schemas.microsoft.com/office/drawing/2014/main" id="{9F44AD79-4B6B-97A0-B713-685142049308}"/>
               </a:ext>
             </a:extLst>
           </p:cNvPr>
@@ -441,7 +441,7 @@
           <p:cNvPr id="4" name="Date Placeholder 3">
             <a:extLst>
               <a:ext uri="{FF2B5EF4-FFF2-40B4-BE49-F238E27FC236}">
-                <a16:creationId xmlns:a16="http://schemas.microsoft.com/office/drawing/2014/main" id="{727105AE-86A5-7A18-BEF4-2CFB8CBA299C}"/>
+                <a16:creationId xmlns:a16="http://schemas.microsoft.com/office/drawing/2014/main" id="{39930048-5C83-9BD1-D73C-A97F3345BA46}"/>
               </a:ext>
             </a:extLst>
           </p:cNvPr>
@@ -457,7 +457,7 @@
           <a:bodyPr/>
           <a:lstStyle/>
           <a:p>
-            <a:fld id="{7CBE9ABB-B08B-4478-9A87-2E9A09899291}" type="datetimeFigureOut">
+            <a:fld id="{E9FEBD7B-8EB1-423A-95BC-1767948C3A44}" type="datetimeFigureOut">
               <a:rPr lang="en-IN" smtClean="0"/>
               <a:t>09-05-2026</a:t>
             </a:fld>
@@ -470,7 +470,7 @@
           <p:cNvPr id="5" name="Footer Placeholder 4">
             <a:extLst>
               <a:ext uri="{FF2B5EF4-FFF2-40B4-BE49-F238E27FC236}">
-                <a16:creationId xmlns:a16="http://schemas.microsoft.com/office/drawing/2014/main" id="{58DFE008-0D20-121B-ABF3-7F47409D1B08}"/>
+                <a16:creationId xmlns:a16="http://schemas.microsoft.com/office/drawing/2014/main" id="{01353821-A22D-04FA-3CDF-B1579FC6813F}"/>
               </a:ext>
             </a:extLst>
           </p:cNvPr>
@@ -495,7 +495,7 @@
           <p:cNvPr id="6" name="Slide Number Placeholder 5">
             <a:extLst>
               <a:ext uri="{FF2B5EF4-FFF2-40B4-BE49-F238E27FC236}">
-                <a16:creationId xmlns:a16="http://schemas.microsoft.com/office/drawing/2014/main" id="{58B61A96-294F-6AA8-4618-25BD1A0A8BCC}"/>
+                <a16:creationId xmlns:a16="http://schemas.microsoft.com/office/drawing/2014/main" id="{02785FF5-420F-9F32-6E6D-D00375089BDD}"/>
               </a:ext>
             </a:extLst>
           </p:cNvPr>
@@ -511,7 +511,7 @@
           <a:bodyPr/>
           <a:lstStyle/>
           <a:p>
-            <a:fld id="{29FAEB51-C480-4927-8D63-D7E8CA2D0755}" type="slidenum">
+            <a:fld id="{7D3154C7-F847-4D8D-B672-35AC6CDDB69A}" type="slidenum">
               <a:rPr lang="en-IN" smtClean="0"/>
               <a:t>‹#›</a:t>
             </a:fld>
@@ -522,7 +522,7 @@
     </p:spTree>
     <p:extLst>
       <p:ext uri="{BB962C8B-B14F-4D97-AF65-F5344CB8AC3E}">
-        <p14:creationId xmlns:p14="http://schemas.microsoft.com/office/powerpoint/2010/main" val="1774913208"/>
+        <p14:creationId xmlns:p14="http://schemas.microsoft.com/office/powerpoint/2010/main" val="1076932834"/>
       </p:ext>
     </p:extLst>
   </p:cSld>
@@ -554,7 +554,7 @@
           <p:cNvPr id="2" name="Vertical Title 1">
             <a:extLst>
               <a:ext uri="{FF2B5EF4-FFF2-40B4-BE49-F238E27FC236}">
-                <a16:creationId xmlns:a16="http://schemas.microsoft.com/office/drawing/2014/main" id="{C19463FD-63FC-DD49-2797-8F1C7107B36F}"/>
+                <a16:creationId xmlns:a16="http://schemas.microsoft.com/office/drawing/2014/main" id="{649831A0-2BDA-A985-2E71-04136D6216C5}"/>
               </a:ext>
             </a:extLst>
           </p:cNvPr>
@@ -588,7 +588,7 @@
           <p:cNvPr id="3" name="Vertical Text Placeholder 2">
             <a:extLst>
               <a:ext uri="{FF2B5EF4-FFF2-40B4-BE49-F238E27FC236}">
-                <a16:creationId xmlns:a16="http://schemas.microsoft.com/office/drawing/2014/main" id="{D190FACA-9BF7-BD5A-A8EC-B20C24281EEE}"/>
+                <a16:creationId xmlns:a16="http://schemas.microsoft.com/office/drawing/2014/main" id="{56040E70-5D1D-9167-3556-2D0C7BDFF810}"/>
               </a:ext>
             </a:extLst>
           </p:cNvPr>
@@ -651,7 +651,7 @@
           <p:cNvPr id="4" name="Date Placeholder 3">
             <a:extLst>
               <a:ext uri="{FF2B5EF4-FFF2-40B4-BE49-F238E27FC236}">
-                <a16:creationId xmlns:a16="http://schemas.microsoft.com/office/drawing/2014/main" id="{5B574FFF-01A0-3FB7-9AFD-79F2A9D6706B}"/>
+                <a16:creationId xmlns:a16="http://schemas.microsoft.com/office/drawing/2014/main" id="{E2C38BBB-B8CB-4741-730A-CB9BFF02CAE3}"/>
               </a:ext>
             </a:extLst>
           </p:cNvPr>
@@ -667,7 +667,7 @@
           <a:bodyPr/>
           <a:lstStyle/>
           <a:p>
-            <a:fld id="{7CBE9ABB-B08B-4478-9A87-2E9A09899291}" type="datetimeFigureOut">
+            <a:fld id="{E9FEBD7B-8EB1-423A-95BC-1767948C3A44}" type="datetimeFigureOut">
               <a:rPr lang="en-IN" smtClean="0"/>
               <a:t>09-05-2026</a:t>
             </a:fld>
@@ -680,7 +680,7 @@
           <p:cNvPr id="5" name="Footer Placeholder 4">
             <a:extLst>
               <a:ext uri="{FF2B5EF4-FFF2-40B4-BE49-F238E27FC236}">
-                <a16:creationId xmlns:a16="http://schemas.microsoft.com/office/drawing/2014/main" id="{91FD91B1-7C99-3BDD-8149-6B7A76021B4D}"/>
+                <a16:creationId xmlns:a16="http://schemas.microsoft.com/office/drawing/2014/main" id="{D3DF2D50-D042-8A19-D34E-368BF8B4372F}"/>
               </a:ext>
             </a:extLst>
           </p:cNvPr>
@@ -705,7 +705,7 @@
           <p:cNvPr id="6" name="Slide Number Placeholder 5">
             <a:extLst>
               <a:ext uri="{FF2B5EF4-FFF2-40B4-BE49-F238E27FC236}">
-                <a16:creationId xmlns:a16="http://schemas.microsoft.com/office/drawing/2014/main" id="{EC62B13F-AAA4-264C-D69C-5A1376B4D7AC}"/>
+                <a16:creationId xmlns:a16="http://schemas.microsoft.com/office/drawing/2014/main" id="{E9E87D4C-1DC8-6AE8-A34E-069DBAD12726}"/>
               </a:ext>
             </a:extLst>
           </p:cNvPr>
@@ -721,7 +721,7 @@
           <a:bodyPr/>
           <a:lstStyle/>
           <a:p>
-            <a:fld id="{29FAEB51-C480-4927-8D63-D7E8CA2D0755}" type="slidenum">
+            <a:fld id="{7D3154C7-F847-4D8D-B672-35AC6CDDB69A}" type="slidenum">
               <a:rPr lang="en-IN" smtClean="0"/>
               <a:t>‹#›</a:t>
             </a:fld>
@@ -732,7 +732,7 @@
     </p:spTree>
     <p:extLst>
       <p:ext uri="{BB962C8B-B14F-4D97-AF65-F5344CB8AC3E}">
-        <p14:creationId xmlns:p14="http://schemas.microsoft.com/office/powerpoint/2010/main" val="3165016725"/>
+        <p14:creationId xmlns:p14="http://schemas.microsoft.com/office/powerpoint/2010/main" val="2514829826"/>
       </p:ext>
     </p:extLst>
   </p:cSld>
@@ -764,7 +764,7 @@
           <p:cNvPr id="2" name="Title 1">
             <a:extLst>
               <a:ext uri="{FF2B5EF4-FFF2-40B4-BE49-F238E27FC236}">
-                <a16:creationId xmlns:a16="http://schemas.microsoft.com/office/drawing/2014/main" id="{62162610-1309-6B1D-0343-D83FDF7BCD4D}"/>
+                <a16:creationId xmlns:a16="http://schemas.microsoft.com/office/drawing/2014/main" id="{23DF5F83-9770-0561-43EE-82D49F1A06BA}"/>
               </a:ext>
             </a:extLst>
           </p:cNvPr>
@@ -793,7 +793,7 @@
           <p:cNvPr id="3" name="Text Placeholder 2">
             <a:extLst>
               <a:ext uri="{FF2B5EF4-FFF2-40B4-BE49-F238E27FC236}">
-                <a16:creationId xmlns:a16="http://schemas.microsoft.com/office/drawing/2014/main" id="{1CB1E814-8973-1711-6E6C-D97C49F5058A}"/>
+                <a16:creationId xmlns:a16="http://schemas.microsoft.com/office/drawing/2014/main" id="{687B3720-FD79-A7BB-0AD5-B689255FC038}"/>
               </a:ext>
             </a:extLst>
           </p:cNvPr>
@@ -851,7 +851,7 @@
           <p:cNvPr id="4" name="Date Placeholder 3">
             <a:extLst>
               <a:ext uri="{FF2B5EF4-FFF2-40B4-BE49-F238E27FC236}">
-                <a16:creationId xmlns:a16="http://schemas.microsoft.com/office/drawing/2014/main" id="{44C870DE-409D-F6D1-C4B0-202A9E9335FE}"/>
+                <a16:creationId xmlns:a16="http://schemas.microsoft.com/office/drawing/2014/main" id="{A18CB826-3C83-215B-6741-8CA6B792E2A6}"/>
               </a:ext>
             </a:extLst>
           </p:cNvPr>
@@ -867,7 +867,7 @@
           <a:bodyPr/>
           <a:lstStyle/>
           <a:p>
-            <a:fld id="{7CBE9ABB-B08B-4478-9A87-2E9A09899291}" type="datetimeFigureOut">
+            <a:fld id="{E9FEBD7B-8EB1-423A-95BC-1767948C3A44}" type="datetimeFigureOut">
               <a:rPr lang="en-IN" smtClean="0"/>
               <a:t>09-05-2026</a:t>
             </a:fld>
@@ -880,7 +880,7 @@
           <p:cNvPr id="5" name="Footer Placeholder 4">
             <a:extLst>
               <a:ext uri="{FF2B5EF4-FFF2-40B4-BE49-F238E27FC236}">
-                <a16:creationId xmlns:a16="http://schemas.microsoft.com/office/drawing/2014/main" id="{0E7BF0B3-2EC6-AC8D-AEA7-15C1A05061DC}"/>
+                <a16:creationId xmlns:a16="http://schemas.microsoft.com/office/drawing/2014/main" id="{36A16CEB-4C25-8438-40C5-1271D9361CBB}"/>
               </a:ext>
             </a:extLst>
           </p:cNvPr>
@@ -905,7 +905,7 @@
           <p:cNvPr id="6" name="Slide Number Placeholder 5">
             <a:extLst>
               <a:ext uri="{FF2B5EF4-FFF2-40B4-BE49-F238E27FC236}">
-                <a16:creationId xmlns:a16="http://schemas.microsoft.com/office/drawing/2014/main" id="{A39E65C2-D369-9BC9-ED60-C0357049226F}"/>
+                <a16:creationId xmlns:a16="http://schemas.microsoft.com/office/drawing/2014/main" id="{9456A5E3-4973-EC45-A3E0-32CE66334621}"/>
               </a:ext>
             </a:extLst>
           </p:cNvPr>
@@ -921,7 +921,7 @@
           <a:bodyPr/>
           <a:lstStyle/>
           <a:p>
-            <a:fld id="{29FAEB51-C480-4927-8D63-D7E8CA2D0755}" type="slidenum">
+            <a:fld id="{7D3154C7-F847-4D8D-B672-35AC6CDDB69A}" type="slidenum">
               <a:rPr lang="en-IN" smtClean="0"/>
               <a:t>‹#›</a:t>
             </a:fld>
@@ -932,7 +932,7 @@
     </p:spTree>
     <p:extLst>
       <p:ext uri="{BB962C8B-B14F-4D97-AF65-F5344CB8AC3E}">
-        <p14:creationId xmlns:p14="http://schemas.microsoft.com/office/powerpoint/2010/main" val="3810477085"/>
+        <p14:creationId xmlns:p14="http://schemas.microsoft.com/office/powerpoint/2010/main" val="3891160979"/>
       </p:ext>
     </p:extLst>
   </p:cSld>
@@ -964,7 +964,7 @@
           <p:cNvPr id="2" name="Title 1">
             <a:extLst>
               <a:ext uri="{FF2B5EF4-FFF2-40B4-BE49-F238E27FC236}">
-                <a16:creationId xmlns:a16="http://schemas.microsoft.com/office/drawing/2014/main" id="{BB1B7A0B-7A28-841B-271F-0D839A333D87}"/>
+                <a16:creationId xmlns:a16="http://schemas.microsoft.com/office/drawing/2014/main" id="{AF276CED-9341-5C9D-D950-E1718F0DF2D6}"/>
               </a:ext>
             </a:extLst>
           </p:cNvPr>
@@ -993,7 +993,7 @@
           <p:cNvPr id="3" name="Content Placeholder 2">
             <a:extLst>
               <a:ext uri="{FF2B5EF4-FFF2-40B4-BE49-F238E27FC236}">
-                <a16:creationId xmlns:a16="http://schemas.microsoft.com/office/drawing/2014/main" id="{D68FCE76-2F99-1D90-EB8F-2C53B632CB9B}"/>
+                <a16:creationId xmlns:a16="http://schemas.microsoft.com/office/drawing/2014/main" id="{505291F1-CD59-D14B-F54E-F0FF0E4F6FCD}"/>
               </a:ext>
             </a:extLst>
           </p:cNvPr>
@@ -1051,7 +1051,7 @@
           <p:cNvPr id="4" name="Date Placeholder 3">
             <a:extLst>
               <a:ext uri="{FF2B5EF4-FFF2-40B4-BE49-F238E27FC236}">
-                <a16:creationId xmlns:a16="http://schemas.microsoft.com/office/drawing/2014/main" id="{D5C68471-8002-FB12-15EE-8C9709D25DA2}"/>
+                <a16:creationId xmlns:a16="http://schemas.microsoft.com/office/drawing/2014/main" id="{EA59E3E9-25D5-7231-ADE6-C42BCA7E519C}"/>
               </a:ext>
             </a:extLst>
           </p:cNvPr>
@@ -1067,7 +1067,7 @@
           <a:bodyPr/>
           <a:lstStyle/>
           <a:p>
-            <a:fld id="{7CBE9ABB-B08B-4478-9A87-2E9A09899291}" type="datetimeFigureOut">
+            <a:fld id="{E9FEBD7B-8EB1-423A-95BC-1767948C3A44}" type="datetimeFigureOut">
               <a:rPr lang="en-IN" smtClean="0"/>
               <a:t>09-05-2026</a:t>
             </a:fld>
@@ -1080,7 +1080,7 @@
           <p:cNvPr id="5" name="Footer Placeholder 4">
             <a:extLst>
               <a:ext uri="{FF2B5EF4-FFF2-40B4-BE49-F238E27FC236}">
-                <a16:creationId xmlns:a16="http://schemas.microsoft.com/office/drawing/2014/main" id="{1D4C1886-44EF-C85B-865D-BFFFF64AB2CD}"/>
+                <a16:creationId xmlns:a16="http://schemas.microsoft.com/office/drawing/2014/main" id="{FCC2AF44-D9B2-C387-F8B2-874159B55B71}"/>
               </a:ext>
             </a:extLst>
           </p:cNvPr>
@@ -1105,7 +1105,7 @@
           <p:cNvPr id="6" name="Slide Number Placeholder 5">
             <a:extLst>
               <a:ext uri="{FF2B5EF4-FFF2-40B4-BE49-F238E27FC236}">
-                <a16:creationId xmlns:a16="http://schemas.microsoft.com/office/drawing/2014/main" id="{77924DE6-0626-BDCB-F02C-E7D8A738BFE0}"/>
+                <a16:creationId xmlns:a16="http://schemas.microsoft.com/office/drawing/2014/main" id="{E3498973-783E-1987-D1A6-2118C759D692}"/>
               </a:ext>
             </a:extLst>
           </p:cNvPr>
@@ -1121,7 +1121,7 @@
           <a:bodyPr/>
           <a:lstStyle/>
           <a:p>
-            <a:fld id="{29FAEB51-C480-4927-8D63-D7E8CA2D0755}" type="slidenum">
+            <a:fld id="{7D3154C7-F847-4D8D-B672-35AC6CDDB69A}" type="slidenum">
               <a:rPr lang="en-IN" smtClean="0"/>
               <a:t>‹#›</a:t>
             </a:fld>
@@ -1132,7 +1132,7 @@
     </p:spTree>
     <p:extLst>
       <p:ext uri="{BB962C8B-B14F-4D97-AF65-F5344CB8AC3E}">
-        <p14:creationId xmlns:p14="http://schemas.microsoft.com/office/powerpoint/2010/main" val="1166344365"/>
+        <p14:creationId xmlns:p14="http://schemas.microsoft.com/office/powerpoint/2010/main" val="1288047385"/>
       </p:ext>
     </p:extLst>
   </p:cSld>
@@ -1164,7 +1164,7 @@
           <p:cNvPr id="2" name="Title 1">
             <a:extLst>
               <a:ext uri="{FF2B5EF4-FFF2-40B4-BE49-F238E27FC236}">
-                <a16:creationId xmlns:a16="http://schemas.microsoft.com/office/drawing/2014/main" id="{62C5A414-BAA7-A9B5-4280-4212861462D1}"/>
+                <a16:creationId xmlns:a16="http://schemas.microsoft.com/office/drawing/2014/main" id="{A5FE6A4E-3883-0276-5A1D-7749984B3F9C}"/>
               </a:ext>
             </a:extLst>
           </p:cNvPr>
@@ -1202,7 +1202,7 @@
           <p:cNvPr id="3" name="Text Placeholder 2">
             <a:extLst>
               <a:ext uri="{FF2B5EF4-FFF2-40B4-BE49-F238E27FC236}">
-                <a16:creationId xmlns:a16="http://schemas.microsoft.com/office/drawing/2014/main" id="{7DD9666F-D29F-09EE-7000-7BE60258578C}"/>
+                <a16:creationId xmlns:a16="http://schemas.microsoft.com/office/drawing/2014/main" id="{EA38D526-3CC4-B5F5-A7E1-65BCCD978FC7}"/>
               </a:ext>
             </a:extLst>
           </p:cNvPr>
@@ -1327,7 +1327,7 @@
           <p:cNvPr id="4" name="Date Placeholder 3">
             <a:extLst>
               <a:ext uri="{FF2B5EF4-FFF2-40B4-BE49-F238E27FC236}">
-                <a16:creationId xmlns:a16="http://schemas.microsoft.com/office/drawing/2014/main" id="{8D8AB6DE-F914-8C60-935A-A4C862652FA7}"/>
+                <a16:creationId xmlns:a16="http://schemas.microsoft.com/office/drawing/2014/main" id="{75A5510E-7CB3-B5C8-6D84-37585951CF6F}"/>
               </a:ext>
             </a:extLst>
           </p:cNvPr>
@@ -1343,7 +1343,7 @@
           <a:bodyPr/>
           <a:lstStyle/>
           <a:p>
-            <a:fld id="{7CBE9ABB-B08B-4478-9A87-2E9A09899291}" type="datetimeFigureOut">
+            <a:fld id="{E9FEBD7B-8EB1-423A-95BC-1767948C3A44}" type="datetimeFigureOut">
               <a:rPr lang="en-IN" smtClean="0"/>
               <a:t>09-05-2026</a:t>
             </a:fld>
@@ -1356,7 +1356,7 @@
           <p:cNvPr id="5" name="Footer Placeholder 4">
             <a:extLst>
               <a:ext uri="{FF2B5EF4-FFF2-40B4-BE49-F238E27FC236}">
-                <a16:creationId xmlns:a16="http://schemas.microsoft.com/office/drawing/2014/main" id="{2342D400-C103-F290-7285-6BED9EA6B8CC}"/>
+                <a16:creationId xmlns:a16="http://schemas.microsoft.com/office/drawing/2014/main" id="{73AC49E0-5AB9-C2B3-6CAD-2CE5CFB1399F}"/>
               </a:ext>
             </a:extLst>
           </p:cNvPr>
@@ -1381,7 +1381,7 @@
           <p:cNvPr id="6" name="Slide Number Placeholder 5">
             <a:extLst>
               <a:ext uri="{FF2B5EF4-FFF2-40B4-BE49-F238E27FC236}">
-                <a16:creationId xmlns:a16="http://schemas.microsoft.com/office/drawing/2014/main" id="{7459B63A-7037-C5AA-25E3-B1F1B491DA89}"/>
+                <a16:creationId xmlns:a16="http://schemas.microsoft.com/office/drawing/2014/main" id="{A5A3E45D-C462-B5F6-3810-9FFFBD82836D}"/>
               </a:ext>
             </a:extLst>
           </p:cNvPr>
@@ -1397,7 +1397,7 @@
           <a:bodyPr/>
           <a:lstStyle/>
           <a:p>
-            <a:fld id="{29FAEB51-C480-4927-8D63-D7E8CA2D0755}" type="slidenum">
+            <a:fld id="{7D3154C7-F847-4D8D-B672-35AC6CDDB69A}" type="slidenum">
               <a:rPr lang="en-IN" smtClean="0"/>
               <a:t>‹#›</a:t>
             </a:fld>
@@ -1408,7 +1408,7 @@
     </p:spTree>
     <p:extLst>
       <p:ext uri="{BB962C8B-B14F-4D97-AF65-F5344CB8AC3E}">
-        <p14:creationId xmlns:p14="http://schemas.microsoft.com/office/powerpoint/2010/main" val="1703947081"/>
+        <p14:creationId xmlns:p14="http://schemas.microsoft.com/office/powerpoint/2010/main" val="1713952886"/>
       </p:ext>
     </p:extLst>
   </p:cSld>
@@ -1440,7 +1440,7 @@
           <p:cNvPr id="2" name="Title 1">
             <a:extLst>
               <a:ext uri="{FF2B5EF4-FFF2-40B4-BE49-F238E27FC236}">
-                <a16:creationId xmlns:a16="http://schemas.microsoft.com/office/drawing/2014/main" id="{1CBD4563-7EC4-2D08-F01A-CCB30F5EEF78}"/>
+                <a16:creationId xmlns:a16="http://schemas.microsoft.com/office/drawing/2014/main" id="{E7920F4C-7D2D-1605-D9C5-9D30FD232627}"/>
               </a:ext>
             </a:extLst>
           </p:cNvPr>
@@ -1469,7 +1469,7 @@
           <p:cNvPr id="3" name="Content Placeholder 2">
             <a:extLst>
               <a:ext uri="{FF2B5EF4-FFF2-40B4-BE49-F238E27FC236}">
-                <a16:creationId xmlns:a16="http://schemas.microsoft.com/office/drawing/2014/main" id="{C14C259F-04BE-521C-69C1-DF31FB0D503F}"/>
+                <a16:creationId xmlns:a16="http://schemas.microsoft.com/office/drawing/2014/main" id="{DC8CC0EA-6B71-A30F-191A-0CDA4C603B11}"/>
               </a:ext>
             </a:extLst>
           </p:cNvPr>
@@ -1532,7 +1532,7 @@
           <p:cNvPr id="4" name="Content Placeholder 3">
             <a:extLst>
               <a:ext uri="{FF2B5EF4-FFF2-40B4-BE49-F238E27FC236}">
-                <a16:creationId xmlns:a16="http://schemas.microsoft.com/office/drawing/2014/main" id="{DBB9C077-F832-23A0-9D92-80EE9C6EF746}"/>
+                <a16:creationId xmlns:a16="http://schemas.microsoft.com/office/drawing/2014/main" id="{9B290FED-44CC-5A90-3673-3B2001148CE9}"/>
               </a:ext>
             </a:extLst>
           </p:cNvPr>
@@ -1595,7 +1595,7 @@
           <p:cNvPr id="5" name="Date Placeholder 4">
             <a:extLst>
               <a:ext uri="{FF2B5EF4-FFF2-40B4-BE49-F238E27FC236}">
-                <a16:creationId xmlns:a16="http://schemas.microsoft.com/office/drawing/2014/main" id="{D0DA7B2B-F7F4-9B51-D244-E7A00397ABC2}"/>
+                <a16:creationId xmlns:a16="http://schemas.microsoft.com/office/drawing/2014/main" id="{238C8FAF-FDD6-D304-9FD5-2A0315B98CFF}"/>
               </a:ext>
             </a:extLst>
           </p:cNvPr>
@@ -1611,7 +1611,7 @@
           <a:bodyPr/>
           <a:lstStyle/>
           <a:p>
-            <a:fld id="{7CBE9ABB-B08B-4478-9A87-2E9A09899291}" type="datetimeFigureOut">
+            <a:fld id="{E9FEBD7B-8EB1-423A-95BC-1767948C3A44}" type="datetimeFigureOut">
               <a:rPr lang="en-IN" smtClean="0"/>
               <a:t>09-05-2026</a:t>
             </a:fld>
@@ -1624,7 +1624,7 @@
           <p:cNvPr id="6" name="Footer Placeholder 5">
             <a:extLst>
               <a:ext uri="{FF2B5EF4-FFF2-40B4-BE49-F238E27FC236}">
-                <a16:creationId xmlns:a16="http://schemas.microsoft.com/office/drawing/2014/main" id="{E6BBE830-C840-2BFF-0297-F6085760B863}"/>
+                <a16:creationId xmlns:a16="http://schemas.microsoft.com/office/drawing/2014/main" id="{656EF286-94FA-5BC9-800A-86A93202F04E}"/>
               </a:ext>
             </a:extLst>
           </p:cNvPr>
@@ -1649,7 +1649,7 @@
           <p:cNvPr id="7" name="Slide Number Placeholder 6">
             <a:extLst>
               <a:ext uri="{FF2B5EF4-FFF2-40B4-BE49-F238E27FC236}">
-                <a16:creationId xmlns:a16="http://schemas.microsoft.com/office/drawing/2014/main" id="{22B71C4A-35CE-E65C-A424-D86C9086AAD7}"/>
+                <a16:creationId xmlns:a16="http://schemas.microsoft.com/office/drawing/2014/main" id="{765E6230-5DFD-2851-2D32-BCD40509EBDB}"/>
               </a:ext>
             </a:extLst>
           </p:cNvPr>
@@ -1665,7 +1665,7 @@
           <a:bodyPr/>
           <a:lstStyle/>
           <a:p>
-            <a:fld id="{29FAEB51-C480-4927-8D63-D7E8CA2D0755}" type="slidenum">
+            <a:fld id="{7D3154C7-F847-4D8D-B672-35AC6CDDB69A}" type="slidenum">
               <a:rPr lang="en-IN" smtClean="0"/>
               <a:t>‹#›</a:t>
             </a:fld>
@@ -1676,7 +1676,7 @@
     </p:spTree>
     <p:extLst>
       <p:ext uri="{BB962C8B-B14F-4D97-AF65-F5344CB8AC3E}">
-        <p14:creationId xmlns:p14="http://schemas.microsoft.com/office/powerpoint/2010/main" val="2545757293"/>
+        <p14:creationId xmlns:p14="http://schemas.microsoft.com/office/powerpoint/2010/main" val="1608885570"/>
       </p:ext>
     </p:extLst>
   </p:cSld>
@@ -1708,7 +1708,7 @@
           <p:cNvPr id="2" name="Title 1">
             <a:extLst>
               <a:ext uri="{FF2B5EF4-FFF2-40B4-BE49-F238E27FC236}">
-                <a16:creationId xmlns:a16="http://schemas.microsoft.com/office/drawing/2014/main" id="{F4D67973-3124-0680-75D5-E8D7C884B47F}"/>
+                <a16:creationId xmlns:a16="http://schemas.microsoft.com/office/drawing/2014/main" id="{CE753C1A-8FED-F081-7087-44B2611E1193}"/>
               </a:ext>
             </a:extLst>
           </p:cNvPr>
@@ -1742,7 +1742,7 @@
           <p:cNvPr id="3" name="Text Placeholder 2">
             <a:extLst>
               <a:ext uri="{FF2B5EF4-FFF2-40B4-BE49-F238E27FC236}">
-                <a16:creationId xmlns:a16="http://schemas.microsoft.com/office/drawing/2014/main" id="{DA46EFBB-3496-910E-19F7-3D7A0A9B1900}"/>
+                <a16:creationId xmlns:a16="http://schemas.microsoft.com/office/drawing/2014/main" id="{40D03900-F3A3-CCA8-737C-8FDF7859A929}"/>
               </a:ext>
             </a:extLst>
           </p:cNvPr>
@@ -1813,7 +1813,7 @@
           <p:cNvPr id="4" name="Content Placeholder 3">
             <a:extLst>
               <a:ext uri="{FF2B5EF4-FFF2-40B4-BE49-F238E27FC236}">
-                <a16:creationId xmlns:a16="http://schemas.microsoft.com/office/drawing/2014/main" id="{C74F4EC6-147D-C6B3-15F7-9B3C7124D89F}"/>
+                <a16:creationId xmlns:a16="http://schemas.microsoft.com/office/drawing/2014/main" id="{4504EE84-08A4-5BE8-9A70-570A153FDE67}"/>
               </a:ext>
             </a:extLst>
           </p:cNvPr>
@@ -1876,7 +1876,7 @@
           <p:cNvPr id="5" name="Text Placeholder 4">
             <a:extLst>
               <a:ext uri="{FF2B5EF4-FFF2-40B4-BE49-F238E27FC236}">
-                <a16:creationId xmlns:a16="http://schemas.microsoft.com/office/drawing/2014/main" id="{68C035BD-898E-67BB-1790-84D22F0C42FF}"/>
+                <a16:creationId xmlns:a16="http://schemas.microsoft.com/office/drawing/2014/main" id="{0E3AB7D8-0D29-7F45-CBE3-28F5258047B9}"/>
               </a:ext>
             </a:extLst>
           </p:cNvPr>
@@ -1947,7 +1947,7 @@
           <p:cNvPr id="6" name="Content Placeholder 5">
             <a:extLst>
               <a:ext uri="{FF2B5EF4-FFF2-40B4-BE49-F238E27FC236}">
-                <a16:creationId xmlns:a16="http://schemas.microsoft.com/office/drawing/2014/main" id="{97AD54B8-6A56-2003-334E-FD5B7A3EC1B0}"/>
+                <a16:creationId xmlns:a16="http://schemas.microsoft.com/office/drawing/2014/main" id="{0FD0E367-7150-8D97-EBC1-09F4B102F134}"/>
               </a:ext>
             </a:extLst>
           </p:cNvPr>
@@ -2010,7 +2010,7 @@
           <p:cNvPr id="7" name="Date Placeholder 6">
             <a:extLst>
               <a:ext uri="{FF2B5EF4-FFF2-40B4-BE49-F238E27FC236}">
-                <a16:creationId xmlns:a16="http://schemas.microsoft.com/office/drawing/2014/main" id="{D1C2BC48-BC56-5C71-3CDB-FC0338EF9C0D}"/>
+                <a16:creationId xmlns:a16="http://schemas.microsoft.com/office/drawing/2014/main" id="{2C9A4EBB-BBDD-003A-1F35-BA013A841AED}"/>
               </a:ext>
             </a:extLst>
           </p:cNvPr>
@@ -2026,7 +2026,7 @@
           <a:bodyPr/>
           <a:lstStyle/>
           <a:p>
-            <a:fld id="{7CBE9ABB-B08B-4478-9A87-2E9A09899291}" type="datetimeFigureOut">
+            <a:fld id="{E9FEBD7B-8EB1-423A-95BC-1767948C3A44}" type="datetimeFigureOut">
               <a:rPr lang="en-IN" smtClean="0"/>
               <a:t>09-05-2026</a:t>
             </a:fld>
@@ -2039,7 +2039,7 @@
           <p:cNvPr id="8" name="Footer Placeholder 7">
             <a:extLst>
               <a:ext uri="{FF2B5EF4-FFF2-40B4-BE49-F238E27FC236}">
-                <a16:creationId xmlns:a16="http://schemas.microsoft.com/office/drawing/2014/main" id="{26937E54-2DF4-BA8D-1706-31FB2C587FC7}"/>
+                <a16:creationId xmlns:a16="http://schemas.microsoft.com/office/drawing/2014/main" id="{36A460E5-A980-7150-62BA-5CC68355E71F}"/>
               </a:ext>
             </a:extLst>
           </p:cNvPr>
@@ -2064,7 +2064,7 @@
           <p:cNvPr id="9" name="Slide Number Placeholder 8">
             <a:extLst>
               <a:ext uri="{FF2B5EF4-FFF2-40B4-BE49-F238E27FC236}">
-                <a16:creationId xmlns:a16="http://schemas.microsoft.com/office/drawing/2014/main" id="{CFF70D0B-2CD1-BD33-B422-4A55FE0895D0}"/>
+                <a16:creationId xmlns:a16="http://schemas.microsoft.com/office/drawing/2014/main" id="{E30609AB-9D55-DAC3-C472-AF192614DF0B}"/>
               </a:ext>
             </a:extLst>
           </p:cNvPr>
@@ -2080,7 +2080,7 @@
           <a:bodyPr/>
           <a:lstStyle/>
           <a:p>
-            <a:fld id="{29FAEB51-C480-4927-8D63-D7E8CA2D0755}" type="slidenum">
+            <a:fld id="{7D3154C7-F847-4D8D-B672-35AC6CDDB69A}" type="slidenum">
               <a:rPr lang="en-IN" smtClean="0"/>
               <a:t>‹#›</a:t>
             </a:fld>
@@ -2091,7 +2091,7 @@
     </p:spTree>
     <p:extLst>
       <p:ext uri="{BB962C8B-B14F-4D97-AF65-F5344CB8AC3E}">
-        <p14:creationId xmlns:p14="http://schemas.microsoft.com/office/powerpoint/2010/main" val="3149185017"/>
+        <p14:creationId xmlns:p14="http://schemas.microsoft.com/office/powerpoint/2010/main" val="777419283"/>
       </p:ext>
     </p:extLst>
   </p:cSld>
@@ -2123,7 +2123,7 @@
           <p:cNvPr id="2" name="Title 1">
             <a:extLst>
               <a:ext uri="{FF2B5EF4-FFF2-40B4-BE49-F238E27FC236}">
-                <a16:creationId xmlns:a16="http://schemas.microsoft.com/office/drawing/2014/main" id="{80DE5DCC-2782-EB45-FFFC-3F4D26CA4A0C}"/>
+                <a16:creationId xmlns:a16="http://schemas.microsoft.com/office/drawing/2014/main" id="{4079B402-EDF7-2F03-D041-F65A7BA4047C}"/>
               </a:ext>
             </a:extLst>
           </p:cNvPr>
@@ -2152,7 +2152,7 @@
           <p:cNvPr id="3" name="Date Placeholder 2">
             <a:extLst>
               <a:ext uri="{FF2B5EF4-FFF2-40B4-BE49-F238E27FC236}">
-                <a16:creationId xmlns:a16="http://schemas.microsoft.com/office/drawing/2014/main" id="{C55C4149-F53A-FE7F-CEF3-F6F057E0866D}"/>
+                <a16:creationId xmlns:a16="http://schemas.microsoft.com/office/drawing/2014/main" id="{71DEABC8-752F-E0EC-AE43-CCDF85E2C046}"/>
               </a:ext>
             </a:extLst>
           </p:cNvPr>
@@ -2168,7 +2168,7 @@
           <a:bodyPr/>
           <a:lstStyle/>
           <a:p>
-            <a:fld id="{7CBE9ABB-B08B-4478-9A87-2E9A09899291}" type="datetimeFigureOut">
+            <a:fld id="{E9FEBD7B-8EB1-423A-95BC-1767948C3A44}" type="datetimeFigureOut">
               <a:rPr lang="en-IN" smtClean="0"/>
               <a:t>09-05-2026</a:t>
             </a:fld>
@@ -2181,7 +2181,7 @@
           <p:cNvPr id="4" name="Footer Placeholder 3">
             <a:extLst>
               <a:ext uri="{FF2B5EF4-FFF2-40B4-BE49-F238E27FC236}">
-                <a16:creationId xmlns:a16="http://schemas.microsoft.com/office/drawing/2014/main" id="{64210F72-27A6-A725-B625-88D019E7F6F1}"/>
+                <a16:creationId xmlns:a16="http://schemas.microsoft.com/office/drawing/2014/main" id="{9832B8B1-4F45-FB56-6E33-B3A60E4D45F4}"/>
               </a:ext>
             </a:extLst>
           </p:cNvPr>
@@ -2206,7 +2206,7 @@
           <p:cNvPr id="5" name="Slide Number Placeholder 4">
             <a:extLst>
               <a:ext uri="{FF2B5EF4-FFF2-40B4-BE49-F238E27FC236}">
-                <a16:creationId xmlns:a16="http://schemas.microsoft.com/office/drawing/2014/main" id="{AD392334-D545-B395-5A29-ABE7853B72C8}"/>
+                <a16:creationId xmlns:a16="http://schemas.microsoft.com/office/drawing/2014/main" id="{93B5EB9F-DD3E-F00C-E27E-CCFCD902E913}"/>
               </a:ext>
             </a:extLst>
           </p:cNvPr>
@@ -2222,7 +2222,7 @@
           <a:bodyPr/>
           <a:lstStyle/>
           <a:p>
-            <a:fld id="{29FAEB51-C480-4927-8D63-D7E8CA2D0755}" type="slidenum">
+            <a:fld id="{7D3154C7-F847-4D8D-B672-35AC6CDDB69A}" type="slidenum">
               <a:rPr lang="en-IN" smtClean="0"/>
               <a:t>‹#›</a:t>
             </a:fld>
@@ -2233,7 +2233,7 @@
     </p:spTree>
     <p:extLst>
       <p:ext uri="{BB962C8B-B14F-4D97-AF65-F5344CB8AC3E}">
-        <p14:creationId xmlns:p14="http://schemas.microsoft.com/office/powerpoint/2010/main" val="1557323622"/>
+        <p14:creationId xmlns:p14="http://schemas.microsoft.com/office/powerpoint/2010/main" val="2800934784"/>
       </p:ext>
     </p:extLst>
   </p:cSld>
@@ -2265,7 +2265,7 @@
           <p:cNvPr id="2" name="Date Placeholder 1">
             <a:extLst>
               <a:ext uri="{FF2B5EF4-FFF2-40B4-BE49-F238E27FC236}">
-                <a16:creationId xmlns:a16="http://schemas.microsoft.com/office/drawing/2014/main" id="{0CDB8712-3CD2-6655-89BE-4D21EB139B4E}"/>
+                <a16:creationId xmlns:a16="http://schemas.microsoft.com/office/drawing/2014/main" id="{81BDFDBD-9258-75C8-BFDD-235E446B7718}"/>
               </a:ext>
             </a:extLst>
           </p:cNvPr>
@@ -2281,7 +2281,7 @@
           <a:bodyPr/>
           <a:lstStyle/>
           <a:p>
-            <a:fld id="{7CBE9ABB-B08B-4478-9A87-2E9A09899291}" type="datetimeFigureOut">
+            <a:fld id="{E9FEBD7B-8EB1-423A-95BC-1767948C3A44}" type="datetimeFigureOut">
               <a:rPr lang="en-IN" smtClean="0"/>
               <a:t>09-05-2026</a:t>
             </a:fld>
@@ -2294,7 +2294,7 @@
           <p:cNvPr id="3" name="Footer Placeholder 2">
             <a:extLst>
               <a:ext uri="{FF2B5EF4-FFF2-40B4-BE49-F238E27FC236}">
-                <a16:creationId xmlns:a16="http://schemas.microsoft.com/office/drawing/2014/main" id="{C93934F3-6C4B-F1BF-CBFB-606913F9E464}"/>
+                <a16:creationId xmlns:a16="http://schemas.microsoft.com/office/drawing/2014/main" id="{A4C9D0B5-7163-75A6-0F14-B60BF9C5DAC5}"/>
               </a:ext>
             </a:extLst>
           </p:cNvPr>
@@ -2319,7 +2319,7 @@
           <p:cNvPr id="4" name="Slide Number Placeholder 3">
             <a:extLst>
               <a:ext uri="{FF2B5EF4-FFF2-40B4-BE49-F238E27FC236}">
-                <a16:creationId xmlns:a16="http://schemas.microsoft.com/office/drawing/2014/main" id="{4BF0966C-CC63-0F03-31CD-4B5AFC2AB364}"/>
+                <a16:creationId xmlns:a16="http://schemas.microsoft.com/office/drawing/2014/main" id="{5ECC5BED-9757-B37B-B3FC-B2788E340D51}"/>
               </a:ext>
             </a:extLst>
           </p:cNvPr>
@@ -2335,7 +2335,7 @@
           <a:bodyPr/>
           <a:lstStyle/>
           <a:p>
-            <a:fld id="{29FAEB51-C480-4927-8D63-D7E8CA2D0755}" type="slidenum">
+            <a:fld id="{7D3154C7-F847-4D8D-B672-35AC6CDDB69A}" type="slidenum">
               <a:rPr lang="en-IN" smtClean="0"/>
               <a:t>‹#›</a:t>
             </a:fld>
@@ -2346,7 +2346,7 @@
     </p:spTree>
     <p:extLst>
       <p:ext uri="{BB962C8B-B14F-4D97-AF65-F5344CB8AC3E}">
-        <p14:creationId xmlns:p14="http://schemas.microsoft.com/office/powerpoint/2010/main" val="2472027668"/>
+        <p14:creationId xmlns:p14="http://schemas.microsoft.com/office/powerpoint/2010/main" val="3577481677"/>
       </p:ext>
     </p:extLst>
   </p:cSld>
@@ -2378,7 +2378,7 @@
           <p:cNvPr id="2" name="Title 1">
             <a:extLst>
               <a:ext uri="{FF2B5EF4-FFF2-40B4-BE49-F238E27FC236}">
-                <a16:creationId xmlns:a16="http://schemas.microsoft.com/office/drawing/2014/main" id="{0C03817F-0DC5-9A69-05B4-D90F95067396}"/>
+                <a16:creationId xmlns:a16="http://schemas.microsoft.com/office/drawing/2014/main" id="{2AAA6048-DA0D-C233-EBED-B6590AE852CC}"/>
               </a:ext>
             </a:extLst>
           </p:cNvPr>
@@ -2416,7 +2416,7 @@
           <p:cNvPr id="3" name="Content Placeholder 2">
             <a:extLst>
               <a:ext uri="{FF2B5EF4-FFF2-40B4-BE49-F238E27FC236}">
-                <a16:creationId xmlns:a16="http://schemas.microsoft.com/office/drawing/2014/main" id="{439C984B-3487-7347-432B-924EF04BEE31}"/>
+                <a16:creationId xmlns:a16="http://schemas.microsoft.com/office/drawing/2014/main" id="{4EA71598-4E7E-25A1-4E24-503E746A9F5D}"/>
               </a:ext>
             </a:extLst>
           </p:cNvPr>
@@ -2507,7 +2507,7 @@
           <p:cNvPr id="4" name="Text Placeholder 3">
             <a:extLst>
               <a:ext uri="{FF2B5EF4-FFF2-40B4-BE49-F238E27FC236}">
-                <a16:creationId xmlns:a16="http://schemas.microsoft.com/office/drawing/2014/main" id="{663342AA-92F9-2370-D1BF-832DDDD54493}"/>
+                <a16:creationId xmlns:a16="http://schemas.microsoft.com/office/drawing/2014/main" id="{1611EACB-91E4-29DD-E81F-3C646035A79C}"/>
               </a:ext>
             </a:extLst>
           </p:cNvPr>
@@ -2578,7 +2578,7 @@
           <p:cNvPr id="5" name="Date Placeholder 4">
             <a:extLst>
               <a:ext uri="{FF2B5EF4-FFF2-40B4-BE49-F238E27FC236}">
-                <a16:creationId xmlns:a16="http://schemas.microsoft.com/office/drawing/2014/main" id="{F9D0E2FD-E63B-5C6C-0790-D95BEF0D5D00}"/>
+                <a16:creationId xmlns:a16="http://schemas.microsoft.com/office/drawing/2014/main" id="{B3BF7C7A-FA20-91B1-CF42-68E53FCB8041}"/>
               </a:ext>
             </a:extLst>
           </p:cNvPr>
@@ -2594,7 +2594,7 @@
           <a:bodyPr/>
           <a:lstStyle/>
           <a:p>
-            <a:fld id="{7CBE9ABB-B08B-4478-9A87-2E9A09899291}" type="datetimeFigureOut">
+            <a:fld id="{E9FEBD7B-8EB1-423A-95BC-1767948C3A44}" type="datetimeFigureOut">
               <a:rPr lang="en-IN" smtClean="0"/>
               <a:t>09-05-2026</a:t>
             </a:fld>
@@ -2607,7 +2607,7 @@
           <p:cNvPr id="6" name="Footer Placeholder 5">
             <a:extLst>
               <a:ext uri="{FF2B5EF4-FFF2-40B4-BE49-F238E27FC236}">
-                <a16:creationId xmlns:a16="http://schemas.microsoft.com/office/drawing/2014/main" id="{C0006CA7-504B-7E6A-E56C-B78C87EC371A}"/>
+                <a16:creationId xmlns:a16="http://schemas.microsoft.com/office/drawing/2014/main" id="{4F116B80-4F6F-CD8F-9E3E-DC9F6C4B78D5}"/>
               </a:ext>
             </a:extLst>
           </p:cNvPr>
@@ -2632,7 +2632,7 @@
           <p:cNvPr id="7" name="Slide Number Placeholder 6">
             <a:extLst>
               <a:ext uri="{FF2B5EF4-FFF2-40B4-BE49-F238E27FC236}">
-                <a16:creationId xmlns:a16="http://schemas.microsoft.com/office/drawing/2014/main" id="{7F44657F-978C-EE1C-BF28-46BA4DCECE14}"/>
+                <a16:creationId xmlns:a16="http://schemas.microsoft.com/office/drawing/2014/main" id="{AFA47C1F-53C4-3CAE-8E8F-ABD2990A20DA}"/>
               </a:ext>
             </a:extLst>
           </p:cNvPr>
@@ -2648,7 +2648,7 @@
           <a:bodyPr/>
           <a:lstStyle/>
           <a:p>
-            <a:fld id="{29FAEB51-C480-4927-8D63-D7E8CA2D0755}" type="slidenum">
+            <a:fld id="{7D3154C7-F847-4D8D-B672-35AC6CDDB69A}" type="slidenum">
               <a:rPr lang="en-IN" smtClean="0"/>
               <a:t>‹#›</a:t>
             </a:fld>
@@ -2659,7 +2659,7 @@
     </p:spTree>
     <p:extLst>
       <p:ext uri="{BB962C8B-B14F-4D97-AF65-F5344CB8AC3E}">
-        <p14:creationId xmlns:p14="http://schemas.microsoft.com/office/powerpoint/2010/main" val="3444527336"/>
+        <p14:creationId xmlns:p14="http://schemas.microsoft.com/office/powerpoint/2010/main" val="2257033977"/>
       </p:ext>
     </p:extLst>
   </p:cSld>
@@ -2691,7 +2691,7 @@
           <p:cNvPr id="2" name="Title 1">
             <a:extLst>
               <a:ext uri="{FF2B5EF4-FFF2-40B4-BE49-F238E27FC236}">
-                <a16:creationId xmlns:a16="http://schemas.microsoft.com/office/drawing/2014/main" id="{BE3CE412-7D20-056D-E1FD-EF3849419B98}"/>
+                <a16:creationId xmlns:a16="http://schemas.microsoft.com/office/drawing/2014/main" id="{D8A3A74E-20E3-595E-48B0-76D909463A8E}"/>
               </a:ext>
             </a:extLst>
           </p:cNvPr>
@@ -2729,7 +2729,7 @@
           <p:cNvPr id="3" name="Picture Placeholder 2">
             <a:extLst>
               <a:ext uri="{FF2B5EF4-FFF2-40B4-BE49-F238E27FC236}">
-                <a16:creationId xmlns:a16="http://schemas.microsoft.com/office/drawing/2014/main" id="{429122F5-64AE-1D59-8748-B3C18B7A6A0D}"/>
+                <a16:creationId xmlns:a16="http://schemas.microsoft.com/office/drawing/2014/main" id="{E6AC8E54-8EA7-22EC-A1E0-010B2C0C5684}"/>
               </a:ext>
             </a:extLst>
           </p:cNvPr>
@@ -2796,7 +2796,7 @@
           <p:cNvPr id="4" name="Text Placeholder 3">
             <a:extLst>
               <a:ext uri="{FF2B5EF4-FFF2-40B4-BE49-F238E27FC236}">
-                <a16:creationId xmlns:a16="http://schemas.microsoft.com/office/drawing/2014/main" id="{9AE46C04-14DC-146D-59ED-4E90C2DE90CD}"/>
+                <a16:creationId xmlns:a16="http://schemas.microsoft.com/office/drawing/2014/main" id="{7CF93FEC-2892-681B-03EA-7F17C1E9DD7F}"/>
               </a:ext>
             </a:extLst>
           </p:cNvPr>
@@ -2867,7 +2867,7 @@
           <p:cNvPr id="5" name="Date Placeholder 4">
             <a:extLst>
               <a:ext uri="{FF2B5EF4-FFF2-40B4-BE49-F238E27FC236}">
-                <a16:creationId xmlns:a16="http://schemas.microsoft.com/office/drawing/2014/main" id="{DADC821D-457C-EE07-FA75-35A9E7E32805}"/>
+                <a16:creationId xmlns:a16="http://schemas.microsoft.com/office/drawing/2014/main" id="{F6DF4809-0732-6161-28DE-5D97488BAF3D}"/>
               </a:ext>
             </a:extLst>
           </p:cNvPr>
@@ -2883,7 +2883,7 @@
           <a:bodyPr/>
           <a:lstStyle/>
           <a:p>
-            <a:fld id="{7CBE9ABB-B08B-4478-9A87-2E9A09899291}" type="datetimeFigureOut">
+            <a:fld id="{E9FEBD7B-8EB1-423A-95BC-1767948C3A44}" type="datetimeFigureOut">
               <a:rPr lang="en-IN" smtClean="0"/>
               <a:t>09-05-2026</a:t>
             </a:fld>
@@ -2896,7 +2896,7 @@
           <p:cNvPr id="6" name="Footer Placeholder 5">
             <a:extLst>
               <a:ext uri="{FF2B5EF4-FFF2-40B4-BE49-F238E27FC236}">
-                <a16:creationId xmlns:a16="http://schemas.microsoft.com/office/drawing/2014/main" id="{309630D7-14B0-7F09-41FF-429C93C7D5D1}"/>
+                <a16:creationId xmlns:a16="http://schemas.microsoft.com/office/drawing/2014/main" id="{6C64F9ED-F23E-B3F3-C4FA-49742098F93E}"/>
               </a:ext>
             </a:extLst>
           </p:cNvPr>
@@ -2921,7 +2921,7 @@
           <p:cNvPr id="7" name="Slide Number Placeholder 6">
             <a:extLst>
               <a:ext uri="{FF2B5EF4-FFF2-40B4-BE49-F238E27FC236}">
-                <a16:creationId xmlns:a16="http://schemas.microsoft.com/office/drawing/2014/main" id="{19821BD0-AEC2-D77F-B6B9-2D8D18C860FC}"/>
+                <a16:creationId xmlns:a16="http://schemas.microsoft.com/office/drawing/2014/main" id="{3342B151-54A9-AC11-3418-A8CB7D87131C}"/>
               </a:ext>
             </a:extLst>
           </p:cNvPr>
@@ -2937,7 +2937,7 @@
           <a:bodyPr/>
           <a:lstStyle/>
           <a:p>
-            <a:fld id="{29FAEB51-C480-4927-8D63-D7E8CA2D0755}" type="slidenum">
+            <a:fld id="{7D3154C7-F847-4D8D-B672-35AC6CDDB69A}" type="slidenum">
               <a:rPr lang="en-IN" smtClean="0"/>
               <a:t>‹#›</a:t>
             </a:fld>
@@ -2948,7 +2948,7 @@
     </p:spTree>
     <p:extLst>
       <p:ext uri="{BB962C8B-B14F-4D97-AF65-F5344CB8AC3E}">
-        <p14:creationId xmlns:p14="http://schemas.microsoft.com/office/powerpoint/2010/main" val="2454024157"/>
+        <p14:creationId xmlns:p14="http://schemas.microsoft.com/office/powerpoint/2010/main" val="3195741104"/>
       </p:ext>
     </p:extLst>
   </p:cSld>
@@ -2985,7 +2985,7 @@
           <p:cNvPr id="2" name="Title Placeholder 1">
             <a:extLst>
               <a:ext uri="{FF2B5EF4-FFF2-40B4-BE49-F238E27FC236}">
-                <a16:creationId xmlns:a16="http://schemas.microsoft.com/office/drawing/2014/main" id="{21BA4EFC-C85B-A1DC-CBD6-34D2C4FD22CE}"/>
+                <a16:creationId xmlns:a16="http://schemas.microsoft.com/office/drawing/2014/main" id="{C565D05F-575F-3274-20F8-2507144DEB00}"/>
               </a:ext>
             </a:extLst>
           </p:cNvPr>
@@ -3024,7 +3024,7 @@
           <p:cNvPr id="3" name="Text Placeholder 2">
             <a:extLst>
               <a:ext uri="{FF2B5EF4-FFF2-40B4-BE49-F238E27FC236}">
-                <a16:creationId xmlns:a16="http://schemas.microsoft.com/office/drawing/2014/main" id="{1F5C7EA3-5CBD-9A17-2047-E240A05A2D6D}"/>
+                <a16:creationId xmlns:a16="http://schemas.microsoft.com/office/drawing/2014/main" id="{B76FD99E-2E3F-10C7-83C0-B9855F012C1D}"/>
               </a:ext>
             </a:extLst>
           </p:cNvPr>
@@ -3092,7 +3092,7 @@
           <p:cNvPr id="4" name="Date Placeholder 3">
             <a:extLst>
               <a:ext uri="{FF2B5EF4-FFF2-40B4-BE49-F238E27FC236}">
-                <a16:creationId xmlns:a16="http://schemas.microsoft.com/office/drawing/2014/main" id="{7B4640CA-672F-A64F-5EF7-4564817B7E15}"/>
+                <a16:creationId xmlns:a16="http://schemas.microsoft.com/office/drawing/2014/main" id="{C58F2680-EA5D-F775-B497-05961639642C}"/>
               </a:ext>
             </a:extLst>
           </p:cNvPr>
@@ -3126,7 +3126,7 @@
             </a:lvl1pPr>
           </a:lstStyle>
           <a:p>
-            <a:fld id="{7CBE9ABB-B08B-4478-9A87-2E9A09899291}" type="datetimeFigureOut">
+            <a:fld id="{E9FEBD7B-8EB1-423A-95BC-1767948C3A44}" type="datetimeFigureOut">
               <a:rPr lang="en-IN" smtClean="0"/>
               <a:t>09-05-2026</a:t>
             </a:fld>
@@ -3139,7 +3139,7 @@
           <p:cNvPr id="5" name="Footer Placeholder 4">
             <a:extLst>
               <a:ext uri="{FF2B5EF4-FFF2-40B4-BE49-F238E27FC236}">
-                <a16:creationId xmlns:a16="http://schemas.microsoft.com/office/drawing/2014/main" id="{FA523903-78FF-7645-DF9D-56406BD3E61B}"/>
+                <a16:creationId xmlns:a16="http://schemas.microsoft.com/office/drawing/2014/main" id="{E65B689C-5C72-30EA-2CD8-82E17F151F82}"/>
               </a:ext>
             </a:extLst>
           </p:cNvPr>
@@ -3182,7 +3182,7 @@
           <p:cNvPr id="6" name="Slide Number Placeholder 5">
             <a:extLst>
               <a:ext uri="{FF2B5EF4-FFF2-40B4-BE49-F238E27FC236}">
-                <a16:creationId xmlns:a16="http://schemas.microsoft.com/office/drawing/2014/main" id="{AFF15741-E5BF-C0FD-80EB-117E846C196D}"/>
+                <a16:creationId xmlns:a16="http://schemas.microsoft.com/office/drawing/2014/main" id="{944C745B-348F-0F5F-D4F9-D8BB411BC271}"/>
               </a:ext>
             </a:extLst>
           </p:cNvPr>
@@ -3216,7 +3216,7 @@
             </a:lvl1pPr>
           </a:lstStyle>
           <a:p>
-            <a:fld id="{29FAEB51-C480-4927-8D63-D7E8CA2D0755}" type="slidenum">
+            <a:fld id="{7D3154C7-F847-4D8D-B672-35AC6CDDB69A}" type="slidenum">
               <a:rPr lang="en-IN" smtClean="0"/>
               <a:t>‹#›</a:t>
             </a:fld>
@@ -3227,7 +3227,7 @@
     </p:spTree>
     <p:extLst>
       <p:ext uri="{BB962C8B-B14F-4D97-AF65-F5344CB8AC3E}">
-        <p14:creationId xmlns:p14="http://schemas.microsoft.com/office/powerpoint/2010/main" val="228433447"/>
+        <p14:creationId xmlns:p14="http://schemas.microsoft.com/office/powerpoint/2010/main" val="1408930098"/>
       </p:ext>
     </p:extLst>
   </p:cSld>
@@ -3551,7 +3551,7 @@
           <p:cNvPr id="2" name="Title 1">
             <a:extLst>
               <a:ext uri="{FF2B5EF4-FFF2-40B4-BE49-F238E27FC236}">
-                <a16:creationId xmlns:a16="http://schemas.microsoft.com/office/drawing/2014/main" id="{92AF1C9E-AB12-1494-62A8-7DC63A1F96D2}"/>
+                <a16:creationId xmlns:a16="http://schemas.microsoft.com/office/drawing/2014/main" id="{DEE8B789-76FF-8A4B-5F4B-EA9D570B62F4}"/>
               </a:ext>
             </a:extLst>
           </p:cNvPr>
@@ -3579,7 +3579,7 @@
           <p:cNvPr id="3" name="Subtitle 2">
             <a:extLst>
               <a:ext uri="{FF2B5EF4-FFF2-40B4-BE49-F238E27FC236}">
-                <a16:creationId xmlns:a16="http://schemas.microsoft.com/office/drawing/2014/main" id="{4296F922-06FC-AD94-C3FA-BF144E601659}"/>
+                <a16:creationId xmlns:a16="http://schemas.microsoft.com/office/drawing/2014/main" id="{0DD2E575-94CC-8949-7AD6-5FC420E80329}"/>
               </a:ext>
             </a:extLst>
           </p:cNvPr>
@@ -3614,7 +3614,7 @@
     </p:spTree>
     <p:extLst>
       <p:ext uri="{BB962C8B-B14F-4D97-AF65-F5344CB8AC3E}">
-        <p14:creationId xmlns:p14="http://schemas.microsoft.com/office/powerpoint/2010/main" val="445491041"/>
+        <p14:creationId xmlns:p14="http://schemas.microsoft.com/office/powerpoint/2010/main" val="2010282844"/>
       </p:ext>
     </p:extLst>
   </p:cSld>
@@ -3646,7 +3646,7 @@
           <p:cNvPr id="2" name="Title 1">
             <a:extLst>
               <a:ext uri="{FF2B5EF4-FFF2-40B4-BE49-F238E27FC236}">
-                <a16:creationId xmlns:a16="http://schemas.microsoft.com/office/drawing/2014/main" id="{DFF01EEE-743F-4627-E14C-6F59042E1B59}"/>
+                <a16:creationId xmlns:a16="http://schemas.microsoft.com/office/drawing/2014/main" id="{72DDF8DE-B90C-7EC4-696D-89CC638A2000}"/>
               </a:ext>
             </a:extLst>
           </p:cNvPr>
@@ -3674,7 +3674,7 @@
           <p:cNvPr id="3" name="Text Placeholder 2">
             <a:extLst>
               <a:ext uri="{FF2B5EF4-FFF2-40B4-BE49-F238E27FC236}">
-                <a16:creationId xmlns:a16="http://schemas.microsoft.com/office/drawing/2014/main" id="{FA7A3E95-9D3C-F72B-A585-AD77FF827D6B}"/>
+                <a16:creationId xmlns:a16="http://schemas.microsoft.com/office/drawing/2014/main" id="{58B91EB7-AF46-28DD-87CD-BD974867DA57}"/>
               </a:ext>
             </a:extLst>
           </p:cNvPr>
@@ -3692,23 +3692,23 @@
           <a:p>
             <a:r>
               <a:rPr lang="en-GB"/>
-              <a:t>First point about r</a:t>
+              <a:t>First point about </a:t>
             </a:r>
             <a:r>
               <a:rPr lang="en-GB" sz="2400"/>
-              <a:t>evenue</a:t>
-            </a:r>
-          </a:p>
-          <a:p>
-            <a:r>
-              <a:rPr lang="en-GB"/>
-              <a:t>Second point with a l</a:t>
+              <a:t>revenue</a:t>
+            </a:r>
+          </a:p>
+          <a:p>
+            <a:r>
+              <a:rPr lang="en-GB"/>
+              <a:t>Second point with a </a:t>
             </a:r>
             <a:r>
               <a:rPr lang="en-GB">
                 <a:hlinkClick r:id="rId2"/>
               </a:rPr>
-              <a:t>ink</a:t>
+              <a:t>link</a:t>
             </a:r>
             <a:endParaRPr lang="en-GB"/>
           </a:p>
@@ -3727,7 +3727,7 @@
     </p:spTree>
     <p:extLst>
       <p:ext uri="{BB962C8B-B14F-4D97-AF65-F5344CB8AC3E}">
-        <p14:creationId xmlns:p14="http://schemas.microsoft.com/office/powerpoint/2010/main" val="3506743671"/>
+        <p14:creationId xmlns:p14="http://schemas.microsoft.com/office/powerpoint/2010/main" val="348803557"/>
       </p:ext>
     </p:extLst>
   </p:cSld>
@@ -3759,7 +3759,7 @@
           <p:cNvPr id="2" name="Title 1">
             <a:extLst>
               <a:ext uri="{FF2B5EF4-FFF2-40B4-BE49-F238E27FC236}">
-                <a16:creationId xmlns:a16="http://schemas.microsoft.com/office/drawing/2014/main" id="{0C09A858-F714-6A25-F832-1D5350157727}"/>
+                <a16:creationId xmlns:a16="http://schemas.microsoft.com/office/drawing/2014/main" id="{E1152221-F41B-F371-A8D8-774A66B74B2A}"/>
               </a:ext>
             </a:extLst>
           </p:cNvPr>
@@ -3787,7 +3787,7 @@
           <p:cNvPr id="3" name="Subtitle 2">
             <a:extLst>
               <a:ext uri="{FF2B5EF4-FFF2-40B4-BE49-F238E27FC236}">
-                <a16:creationId xmlns:a16="http://schemas.microsoft.com/office/drawing/2014/main" id="{DC4A41E6-13F4-2D4B-ECFC-820946F37CBC}"/>
+                <a16:creationId xmlns:a16="http://schemas.microsoft.com/office/drawing/2014/main" id="{C28C731D-DA57-1892-BE2D-388226D7684A}"/>
               </a:ext>
             </a:extLst>
           </p:cNvPr>
@@ -3831,7 +3831,7 @@
     </p:spTree>
     <p:extLst>
       <p:ext uri="{BB962C8B-B14F-4D97-AF65-F5344CB8AC3E}">
-        <p14:creationId xmlns:p14="http://schemas.microsoft.com/office/powerpoint/2010/main" val="3192724456"/>
+        <p14:creationId xmlns:p14="http://schemas.microsoft.com/office/powerpoint/2010/main" val="887647280"/>
       </p:ext>
     </p:extLst>
   </p:cSld>
@@ -3863,7 +3863,7 @@
           <p:cNvPr id="2" name="Title 1">
             <a:extLst>
               <a:ext uri="{FF2B5EF4-FFF2-40B4-BE49-F238E27FC236}">
-                <a16:creationId xmlns:a16="http://schemas.microsoft.com/office/drawing/2014/main" id="{4BA05793-7843-723A-A82A-28B9312461D0}"/>
+                <a16:creationId xmlns:a16="http://schemas.microsoft.com/office/drawing/2014/main" id="{AEE0CF5D-0ED7-14E5-2E2E-3DDCE2042E9F}"/>
               </a:ext>
             </a:extLst>
           </p:cNvPr>
@@ -3891,7 +3891,7 @@
           <p:cNvPr id="3" name="Subtitle 2">
             <a:extLst>
               <a:ext uri="{FF2B5EF4-FFF2-40B4-BE49-F238E27FC236}">
-                <a16:creationId xmlns:a16="http://schemas.microsoft.com/office/drawing/2014/main" id="{CE5ED745-6D74-0A16-89E0-49FCF36DCF0C}"/>
+                <a16:creationId xmlns:a16="http://schemas.microsoft.com/office/drawing/2014/main" id="{4A49647C-3BAF-3B1B-BA40-CF40F5CEDD77}"/>
               </a:ext>
             </a:extLst>
           </p:cNvPr>
@@ -3934,7 +3934,7 @@
     </p:spTree>
     <p:extLst>
       <p:ext uri="{BB962C8B-B14F-4D97-AF65-F5344CB8AC3E}">
-        <p14:creationId xmlns:p14="http://schemas.microsoft.com/office/powerpoint/2010/main" val="1081223149"/>
+        <p14:creationId xmlns:p14="http://schemas.microsoft.com/office/powerpoint/2010/main" val="946514896"/>
       </p:ext>
     </p:extLst>
   </p:cSld>

</xml_diff>